<commit_message>
Publish reviewed SlidePoise 0.6 examples
</commit_message>
<xml_diff>
--- a/slidepoise/examples/personal-thinking-system/deliverables/presentation.pptx
+++ b/slidepoise/examples/personal-thinking-system/deliverables/presentation.pptx
@@ -507,7 +507,7 @@
             <a:r>
               <a:rPr lang="en-US" dirty="0"/>
               <a:t>[SlidePoise sources]
-Generated target visual: /Users/henry/Codes/AI_slide_drafting/output/showcase-revisions/personal-v2-authoring/slides/s01-opening/work/accepted-slide.png</a:t>
+Generated target visual: /Users/henry/Codes/AI_slide_drafting/examples/personal-thinking-system/run/slides/s01-opening/work/accepted-slide.png</a:t>
             </a:r>
             <a:endParaRPr lang="en-US" dirty="0"/>
           </a:p>
@@ -596,7 +596,7 @@
             <a:r>
               <a:rPr lang="en-US" dirty="0"/>
               <a:t>[SlidePoise sources]
-Generated target visual: /Users/henry/Codes/AI_slide_drafting/output/showcase-revisions/personal-v2-authoring/slides/s02-question/work/accepted-slide.png</a:t>
+Generated target visual: /Users/henry/Codes/AI_slide_drafting/examples/personal-thinking-system/run/slides/s02-question/work/accepted-slide.png</a:t>
             </a:r>
             <a:endParaRPr lang="en-US" dirty="0"/>
           </a:p>
@@ -685,7 +685,7 @@
             <a:r>
               <a:rPr lang="en-US" dirty="0"/>
               <a:t>[SlidePoise sources]
-Generated target visual: /Users/henry/Codes/AI_slide_drafting/output/showcase-revisions/personal-v2-authoring/slides/s03-practice/work/accepted-slide.png</a:t>
+Generated target visual: /Users/henry/Codes/AI_slide_drafting/examples/personal-thinking-system/run/slides/s03-practice/work/accepted-slide.png</a:t>
             </a:r>
             <a:endParaRPr lang="en-US" dirty="0"/>
           </a:p>
@@ -774,7 +774,7 @@
             <a:r>
               <a:rPr lang="en-US" dirty="0"/>
               <a:t>[SlidePoise sources]
-Generated target visual: /Users/henry/Codes/AI_slide_drafting/output/showcase-revisions/personal-v2-authoring/slides/s04-trace/work/accepted-slide.png</a:t>
+Generated target visual: /Users/henry/Codes/AI_slide_drafting/examples/personal-thinking-system/run/slides/s04-trace/work/accepted-slide.png</a:t>
             </a:r>
             <a:endParaRPr lang="en-US" dirty="0"/>
           </a:p>
@@ -863,7 +863,7 @@
             <a:r>
               <a:rPr lang="en-US" dirty="0"/>
               <a:t>[SlidePoise sources]
-Generated target visual: /Users/henry/Codes/AI_slide_drafting/output/showcase-revisions/personal-v2-authoring/slides/s05-close/work/accepted-slide.png</a:t>
+Generated target visual: /Users/henry/Codes/AI_slide_drafting/examples/personal-thinking-system/run/slides/s05-close/work/accepted-slide.png</a:t>
             </a:r>
             <a:endParaRPr lang="en-US" dirty="0"/>
           </a:p>
@@ -3884,7 +3884,7 @@
         </p:nvSpPr>
         <p:spPr>
           <a:xfrm>
-            <a:off x="1013460" y="571500"/>
+            <a:off x="1013460" y="640080"/>
             <a:ext cx="6560820" cy="1463040"/>
           </a:xfrm>
           <a:prstGeom prst="rect">
@@ -3907,17 +3907,17 @@
               <a:defRPr spc="0"/>
             </a:pPr>
             <a:r>
-              <a:rPr lang="en-US" sz="10050" dirty="0" spc="0">
-                <a:solidFill>
-                  <a:srgbClr val="242321"/>
-                </a:solidFill>
-                <a:latin typeface="Bodoni 72" pitchFamily="34" charset="0"/>
-                <a:ea typeface="Bodoni 72" pitchFamily="34" charset="-122"/>
-                <a:cs typeface="Bodoni 72" pitchFamily="34" charset="-120"/>
+              <a:rPr lang="en-US" sz="8600" dirty="0" spc="0">
+                <a:solidFill>
+                  <a:srgbClr val="242321"/>
+                </a:solidFill>
+                <a:latin typeface="Georgia" pitchFamily="34" charset="0"/>
+                <a:ea typeface="Georgia" pitchFamily="34" charset="-122"/>
+                <a:cs typeface="Georgia" pitchFamily="34" charset="-120"/>
               </a:rPr>
               <a:t>The point of</a:t>
             </a:r>
-            <a:endParaRPr lang="en-US" sz="10050" dirty="0" spc="0"/>
+            <a:endParaRPr lang="en-US" sz="8600" dirty="0" spc="0"/>
           </a:p>
         </p:txBody>
       </p:sp>
@@ -3929,7 +3929,7 @@
         </p:nvSpPr>
         <p:spPr>
           <a:xfrm>
-            <a:off x="1013460" y="1813560"/>
+            <a:off x="1013460" y="1889760"/>
             <a:ext cx="6560820" cy="1463040"/>
           </a:xfrm>
           <a:prstGeom prst="rect">
@@ -3952,17 +3952,17 @@
               <a:defRPr spc="0"/>
             </a:pPr>
             <a:r>
-              <a:rPr lang="en-US" sz="10050" dirty="0" spc="0">
-                <a:solidFill>
-                  <a:srgbClr val="242321"/>
-                </a:solidFill>
-                <a:latin typeface="Bodoni 72" pitchFamily="34" charset="0"/>
-                <a:ea typeface="Bodoni 72" pitchFamily="34" charset="-122"/>
-                <a:cs typeface="Bodoni 72" pitchFamily="34" charset="-120"/>
+              <a:rPr lang="en-US" sz="8600" dirty="0" spc="0">
+                <a:solidFill>
+                  <a:srgbClr val="242321"/>
+                </a:solidFill>
+                <a:latin typeface="Georgia" pitchFamily="34" charset="0"/>
+                <a:ea typeface="Georgia" pitchFamily="34" charset="-122"/>
+                <a:cs typeface="Georgia" pitchFamily="34" charset="-120"/>
               </a:rPr>
               <a:t>view is still</a:t>
             </a:r>
-            <a:endParaRPr lang="en-US" sz="10050" dirty="0" spc="0"/>
+            <a:endParaRPr lang="en-US" sz="8600" dirty="0" spc="0"/>
           </a:p>
         </p:txBody>
       </p:sp>
@@ -3974,7 +3974,7 @@
         </p:nvSpPr>
         <p:spPr>
           <a:xfrm>
-            <a:off x="1013460" y="2895600"/>
+            <a:off x="1013460" y="2964180"/>
             <a:ext cx="6560820" cy="1546860"/>
           </a:xfrm>
           <a:prstGeom prst="rect">
@@ -3997,17 +3997,17 @@
               <a:defRPr spc="0"/>
             </a:pPr>
             <a:r>
-              <a:rPr lang="en-US" sz="10050" dirty="0" spc="0">
-                <a:solidFill>
-                  <a:srgbClr val="242321"/>
-                </a:solidFill>
-                <a:latin typeface="Bodoni 72" pitchFamily="34" charset="0"/>
-                <a:ea typeface="Bodoni 72" pitchFamily="34" charset="-122"/>
-                <a:cs typeface="Bodoni 72" pitchFamily="34" charset="-120"/>
+              <a:rPr lang="en-US" sz="8600" dirty="0" spc="0">
+                <a:solidFill>
+                  <a:srgbClr val="242321"/>
+                </a:solidFill>
+                <a:latin typeface="Georgia" pitchFamily="34" charset="0"/>
+                <a:ea typeface="Georgia" pitchFamily="34" charset="-122"/>
+                <a:cs typeface="Georgia" pitchFamily="34" charset="-120"/>
               </a:rPr>
               <a:t>yours.</a:t>
             </a:r>
-            <a:endParaRPr lang="en-US" sz="10050" dirty="0" spc="0"/>
+            <a:endParaRPr lang="en-US" sz="8600" dirty="0" spc="0"/>
           </a:p>
         </p:txBody>
       </p:sp>
@@ -4242,7 +4242,7 @@
     </a:clrScheme>
     <a:fontScheme name="Office">
       <a:majorFont>
-        <a:latin typeface="Bodoni 72"/>
+        <a:latin typeface="Georgia"/>
         <a:ea typeface=""/>
         <a:cs typeface=""/>
         <a:font script="Jpan" typeface="游ゴシック Light"/>

</xml_diff>